<commit_message>
Stabilize deck generator assets
Co-authored-by: anthonyleedu <anthonyleedu@users.noreply.github.com>
</commit_message>
<xml_diff>
--- a/Samuel Space Organ and Tissue Engineering - Investor Presentation (2).pptx
+++ b/Samuel Space Organ and Tissue Engineering - Investor Presentation (2).pptx
@@ -7236,7 +7236,7 @@
             <a:r>
               <a:rPr sz="960" b="0">
                 <a:solidFill>
-                  <a:srgbClr val="13B8A9"/>
+                  <a:srgbClr val="24314A"/>
                 </a:solidFill>
                 <a:latin typeface="Aptos"/>
               </a:rPr>
@@ -7252,7 +7252,7 @@
             <a:r>
               <a:rPr sz="960" b="0">
                 <a:solidFill>
-                  <a:srgbClr val="13B8A9"/>
+                  <a:srgbClr val="24314A"/>
                 </a:solidFill>
                 <a:latin typeface="Aptos"/>
               </a:rPr>
@@ -7268,7 +7268,7 @@
             <a:r>
               <a:rPr sz="960" b="0">
                 <a:solidFill>
-                  <a:srgbClr val="13B8A9"/>
+                  <a:srgbClr val="24314A"/>
                 </a:solidFill>
                 <a:latin typeface="Aptos"/>
               </a:rPr>
@@ -7284,7 +7284,7 @@
             <a:r>
               <a:rPr sz="960" b="0">
                 <a:solidFill>
-                  <a:srgbClr val="13B8A9"/>
+                  <a:srgbClr val="24314A"/>
                 </a:solidFill>
                 <a:latin typeface="Aptos"/>
               </a:rPr>
@@ -7626,7 +7626,7 @@
             <a:r>
               <a:rPr sz="960" b="0">
                 <a:solidFill>
-                  <a:srgbClr val="13B8A9"/>
+                  <a:srgbClr val="24314A"/>
                 </a:solidFill>
                 <a:latin typeface="Aptos"/>
               </a:rPr>
@@ -7642,7 +7642,7 @@
             <a:r>
               <a:rPr sz="960" b="0">
                 <a:solidFill>
-                  <a:srgbClr val="13B8A9"/>
+                  <a:srgbClr val="24314A"/>
                 </a:solidFill>
                 <a:latin typeface="Aptos"/>
               </a:rPr>
@@ -7658,7 +7658,7 @@
             <a:r>
               <a:rPr sz="960" b="0">
                 <a:solidFill>
-                  <a:srgbClr val="13B8A9"/>
+                  <a:srgbClr val="24314A"/>
                 </a:solidFill>
                 <a:latin typeface="Aptos"/>
               </a:rPr>
@@ -7674,7 +7674,7 @@
             <a:r>
               <a:rPr sz="960" b="0">
                 <a:solidFill>
-                  <a:srgbClr val="13B8A9"/>
+                  <a:srgbClr val="24314A"/>
                 </a:solidFill>
                 <a:latin typeface="Aptos"/>
               </a:rPr>
@@ -8016,7 +8016,7 @@
             <a:r>
               <a:rPr sz="960" b="0">
                 <a:solidFill>
-                  <a:srgbClr val="13B8A9"/>
+                  <a:srgbClr val="24314A"/>
                 </a:solidFill>
                 <a:latin typeface="Aptos"/>
               </a:rPr>
@@ -8032,7 +8032,7 @@
             <a:r>
               <a:rPr sz="960" b="0">
                 <a:solidFill>
-                  <a:srgbClr val="13B8A9"/>
+                  <a:srgbClr val="24314A"/>
                 </a:solidFill>
                 <a:latin typeface="Aptos"/>
               </a:rPr>
@@ -8048,7 +8048,7 @@
             <a:r>
               <a:rPr sz="960" b="0">
                 <a:solidFill>
-                  <a:srgbClr val="13B8A9"/>
+                  <a:srgbClr val="24314A"/>
                 </a:solidFill>
                 <a:latin typeface="Aptos"/>
               </a:rPr>
@@ -8064,7 +8064,7 @@
             <a:r>
               <a:rPr sz="960" b="0">
                 <a:solidFill>
-                  <a:srgbClr val="13B8A9"/>
+                  <a:srgbClr val="24314A"/>
                 </a:solidFill>
                 <a:latin typeface="Aptos"/>
               </a:rPr>
@@ -8406,7 +8406,7 @@
             <a:r>
               <a:rPr sz="960" b="0">
                 <a:solidFill>
-                  <a:srgbClr val="13B8A9"/>
+                  <a:srgbClr val="24314A"/>
                 </a:solidFill>
                 <a:latin typeface="Aptos"/>
               </a:rPr>
@@ -8422,7 +8422,7 @@
             <a:r>
               <a:rPr sz="960" b="0">
                 <a:solidFill>
-                  <a:srgbClr val="13B8A9"/>
+                  <a:srgbClr val="24314A"/>
                 </a:solidFill>
                 <a:latin typeface="Aptos"/>
               </a:rPr>
@@ -8438,7 +8438,7 @@
             <a:r>
               <a:rPr sz="960" b="0">
                 <a:solidFill>
-                  <a:srgbClr val="13B8A9"/>
+                  <a:srgbClr val="24314A"/>
                 </a:solidFill>
                 <a:latin typeface="Aptos"/>
               </a:rPr>
@@ -8454,7 +8454,7 @@
             <a:r>
               <a:rPr sz="960" b="0">
                 <a:solidFill>
-                  <a:srgbClr val="13B8A9"/>
+                  <a:srgbClr val="24314A"/>
                 </a:solidFill>
                 <a:latin typeface="Aptos"/>
               </a:rPr>
@@ -15527,7 +15527,7 @@
             <a:r>
               <a:rPr sz="1000" b="0">
                 <a:solidFill>
-                  <a:srgbClr val="13B8A9"/>
+                  <a:srgbClr val="24314A"/>
                 </a:solidFill>
                 <a:latin typeface="Aptos"/>
               </a:rPr>
@@ -15543,7 +15543,7 @@
             <a:r>
               <a:rPr sz="1000" b="0">
                 <a:solidFill>
-                  <a:srgbClr val="13B8A9"/>
+                  <a:srgbClr val="24314A"/>
                 </a:solidFill>
                 <a:latin typeface="Aptos"/>
               </a:rPr>
@@ -15559,7 +15559,7 @@
             <a:r>
               <a:rPr sz="1000" b="0">
                 <a:solidFill>
-                  <a:srgbClr val="13B8A9"/>
+                  <a:srgbClr val="24314A"/>
                 </a:solidFill>
                 <a:latin typeface="Aptos"/>
               </a:rPr>
@@ -15575,7 +15575,7 @@
             <a:r>
               <a:rPr sz="1000" b="0">
                 <a:solidFill>
-                  <a:srgbClr val="13B8A9"/>
+                  <a:srgbClr val="24314A"/>
                 </a:solidFill>
                 <a:latin typeface="Aptos"/>
               </a:rPr>
@@ -15591,7 +15591,7 @@
             <a:r>
               <a:rPr sz="1000" b="0">
                 <a:solidFill>
-                  <a:srgbClr val="13B8A9"/>
+                  <a:srgbClr val="24314A"/>
                 </a:solidFill>
                 <a:latin typeface="Aptos"/>
               </a:rPr>
@@ -19537,7 +19537,7 @@
             <a:r>
               <a:rPr sz="890" b="0">
                 <a:solidFill>
-                  <a:srgbClr val="13B8A9"/>
+                  <a:srgbClr val="24314A"/>
                 </a:solidFill>
                 <a:latin typeface="Aptos"/>
               </a:rPr>
@@ -19553,7 +19553,7 @@
             <a:r>
               <a:rPr sz="890" b="0">
                 <a:solidFill>
-                  <a:srgbClr val="13B8A9"/>
+                  <a:srgbClr val="24314A"/>
                 </a:solidFill>
                 <a:latin typeface="Aptos"/>
               </a:rPr>
@@ -19569,7 +19569,7 @@
             <a:r>
               <a:rPr sz="890" b="0">
                 <a:solidFill>
-                  <a:srgbClr val="13B8A9"/>
+                  <a:srgbClr val="24314A"/>
                 </a:solidFill>
                 <a:latin typeface="Aptos"/>
               </a:rPr>
@@ -19585,7 +19585,7 @@
             <a:r>
               <a:rPr sz="890" b="0">
                 <a:solidFill>
-                  <a:srgbClr val="13B8A9"/>
+                  <a:srgbClr val="24314A"/>
                 </a:solidFill>
                 <a:latin typeface="Aptos"/>
               </a:rPr>
@@ -19601,7 +19601,7 @@
             <a:r>
               <a:rPr sz="890" b="0">
                 <a:solidFill>
-                  <a:srgbClr val="13B8A9"/>
+                  <a:srgbClr val="24314A"/>
                 </a:solidFill>
                 <a:latin typeface="Aptos"/>
               </a:rPr>
@@ -19617,7 +19617,7 @@
             <a:r>
               <a:rPr sz="890" b="0">
                 <a:solidFill>
-                  <a:srgbClr val="13B8A9"/>
+                  <a:srgbClr val="24314A"/>
                 </a:solidFill>
                 <a:latin typeface="Aptos"/>
               </a:rPr>
@@ -19633,7 +19633,7 @@
             <a:r>
               <a:rPr sz="890" b="0">
                 <a:solidFill>
-                  <a:srgbClr val="13B8A9"/>
+                  <a:srgbClr val="24314A"/>
                 </a:solidFill>
                 <a:latin typeface="Aptos"/>
               </a:rPr>
@@ -19714,7 +19714,7 @@
             <a:r>
               <a:rPr sz="890" b="0">
                 <a:solidFill>
-                  <a:srgbClr val="13B8A9"/>
+                  <a:srgbClr val="24314A"/>
                 </a:solidFill>
                 <a:latin typeface="Aptos"/>
               </a:rPr>
@@ -19730,7 +19730,7 @@
             <a:r>
               <a:rPr sz="890" b="0">
                 <a:solidFill>
-                  <a:srgbClr val="13B8A9"/>
+                  <a:srgbClr val="24314A"/>
                 </a:solidFill>
                 <a:latin typeface="Aptos"/>
               </a:rPr>
@@ -19746,7 +19746,7 @@
             <a:r>
               <a:rPr sz="890" b="0">
                 <a:solidFill>
-                  <a:srgbClr val="13B8A9"/>
+                  <a:srgbClr val="24314A"/>
                 </a:solidFill>
                 <a:latin typeface="Aptos"/>
               </a:rPr>
@@ -19762,7 +19762,7 @@
             <a:r>
               <a:rPr sz="890" b="0">
                 <a:solidFill>
-                  <a:srgbClr val="13B8A9"/>
+                  <a:srgbClr val="24314A"/>
                 </a:solidFill>
                 <a:latin typeface="Aptos"/>
               </a:rPr>
@@ -19778,7 +19778,7 @@
             <a:r>
               <a:rPr sz="890" b="0">
                 <a:solidFill>
-                  <a:srgbClr val="13B8A9"/>
+                  <a:srgbClr val="24314A"/>
                 </a:solidFill>
                 <a:latin typeface="Aptos"/>
               </a:rPr>
@@ -19794,7 +19794,7 @@
             <a:r>
               <a:rPr sz="890" b="0">
                 <a:solidFill>
-                  <a:srgbClr val="13B8A9"/>
+                  <a:srgbClr val="24314A"/>
                 </a:solidFill>
                 <a:latin typeface="Aptos"/>
               </a:rPr>
@@ -19810,7 +19810,7 @@
             <a:r>
               <a:rPr sz="890" b="0">
                 <a:solidFill>
-                  <a:srgbClr val="13B8A9"/>
+                  <a:srgbClr val="24314A"/>
                 </a:solidFill>
                 <a:latin typeface="Aptos"/>
               </a:rPr>
@@ -19827,8 +19827,8 @@
         </p:nvSpPr>
         <p:spPr>
           <a:xfrm>
-            <a:off x="713232" y="5559552"/>
-            <a:ext cx="10762488" cy="640080"/>
+            <a:off x="713232" y="5504688"/>
+            <a:ext cx="10762488" cy="749808"/>
           </a:xfrm>
           <a:prstGeom prst="roundRect">
             <a:avLst/>
@@ -19872,8 +19872,8 @@
         </p:nvSpPr>
         <p:spPr>
           <a:xfrm>
-            <a:off x="914400" y="5696712"/>
-            <a:ext cx="1737360" cy="164592"/>
+            <a:off x="914400" y="5650992"/>
+            <a:ext cx="2103120" cy="146304"/>
           </a:xfrm>
           <a:prstGeom prst="rect">
             <a:avLst/>
@@ -19895,7 +19895,7 @@
               </a:spcAft>
             </a:pPr>
             <a:r>
-              <a:rPr sz="1080" b="1">
+              <a:rPr sz="1019" b="1">
                 <a:solidFill>
                   <a:srgbClr val="111F3D"/>
                 </a:solidFill>
@@ -19914,8 +19914,8 @@
         </p:nvSpPr>
         <p:spPr>
           <a:xfrm>
-            <a:off x="2304288" y="5669280"/>
-            <a:ext cx="8869680" cy="201168"/>
+            <a:off x="914400" y="5852160"/>
+            <a:ext cx="10222992" cy="164592"/>
           </a:xfrm>
           <a:prstGeom prst="rect">
             <a:avLst/>
@@ -19937,7 +19937,7 @@
               </a:spcAft>
             </a:pPr>
             <a:r>
-              <a:rPr sz="880" b="0">
+              <a:rPr sz="840" b="0">
                 <a:solidFill>
                   <a:srgbClr val="24314A"/>
                 </a:solidFill>
@@ -22657,7 +22657,7 @@
             <a:r>
               <a:rPr sz="1000" b="0">
                 <a:solidFill>
-                  <a:srgbClr val="13B8A9"/>
+                  <a:srgbClr val="24314A"/>
                 </a:solidFill>
                 <a:latin typeface="Aptos"/>
               </a:rPr>
@@ -22673,7 +22673,7 @@
             <a:r>
               <a:rPr sz="1000" b="0">
                 <a:solidFill>
-                  <a:srgbClr val="13B8A9"/>
+                  <a:srgbClr val="24314A"/>
                 </a:solidFill>
                 <a:latin typeface="Aptos"/>
               </a:rPr>
@@ -22689,7 +22689,7 @@
             <a:r>
               <a:rPr sz="1000" b="0">
                 <a:solidFill>
-                  <a:srgbClr val="13B8A9"/>
+                  <a:srgbClr val="24314A"/>
                 </a:solidFill>
                 <a:latin typeface="Aptos"/>
               </a:rPr>
@@ -22728,7 +22728,7 @@
             <a:r>
               <a:rPr sz="1000" b="0">
                 <a:solidFill>
-                  <a:srgbClr val="13B8A9"/>
+                  <a:srgbClr val="24314A"/>
                 </a:solidFill>
                 <a:latin typeface="Aptos"/>
               </a:rPr>
@@ -22744,7 +22744,7 @@
             <a:r>
               <a:rPr sz="1000" b="0">
                 <a:solidFill>
-                  <a:srgbClr val="13B8A9"/>
+                  <a:srgbClr val="24314A"/>
                 </a:solidFill>
                 <a:latin typeface="Aptos"/>
               </a:rPr>
@@ -22760,7 +22760,7 @@
             <a:r>
               <a:rPr sz="1000" b="0">
                 <a:solidFill>
-                  <a:srgbClr val="13B8A9"/>
+                  <a:srgbClr val="24314A"/>
                 </a:solidFill>
                 <a:latin typeface="Aptos"/>
               </a:rPr>

</xml_diff>

<commit_message>
Refine timeline and presentation labels
Co-authored-by: anthonyleedu <anthonyleedu@users.noreply.github.com>
</commit_message>
<xml_diff>
--- a/Samuel Space Organ and Tissue Engineering - Investor Presentation (2).pptx
+++ b/Samuel Space Organ and Tissue Engineering - Investor Presentation (2).pptx
@@ -12928,22 +12928,22 @@
           <p:nvPr/>
         </p:nvSpPr>
         <p:spPr>
-          <a:xfrm rot="16200000">
-            <a:off x="530352" y="1828800"/>
-            <a:ext cx="402336" cy="1783080"/>
-          </a:xfrm>
-          <a:prstGeom prst="rect">
-            <a:avLst/>
-          </a:prstGeom>
-          <a:noFill/>
-        </p:spPr>
-        <p:txBody>
-          <a:bodyPr wrap="square" lIns="0" rIns="0" tIns="0" bIns="0" anchor="ctr">
-            <a:spAutoFit/>
-          </a:bodyPr>
-          <a:lstStyle/>
-          <a:p>
-            <a:pPr algn="ctr">
+          <a:xfrm>
+            <a:off x="1463040" y="2139696"/>
+            <a:ext cx="1554480" cy="164592"/>
+          </a:xfrm>
+          <a:prstGeom prst="rect">
+            <a:avLst/>
+          </a:prstGeom>
+          <a:noFill/>
+        </p:spPr>
+        <p:txBody>
+          <a:bodyPr wrap="square" lIns="0" rIns="0" tIns="0" bIns="0" anchor="t">
+            <a:spAutoFit/>
+          </a:bodyPr>
+          <a:lstStyle/>
+          <a:p>
+            <a:pPr algn="l">
               <a:lnSpc>
                 <a:spcPct val="100000"/>
               </a:lnSpc>
@@ -12955,7 +12955,7 @@
               </a:spcAft>
             </a:pPr>
             <a:r>
-              <a:rPr sz="700" b="1" i="0">
+              <a:rPr sz="660" b="1" i="0">
                 <a:solidFill>
                   <a:srgbClr val="5E7082"/>
                 </a:solidFill>
@@ -12973,22 +12973,22 @@
           <p:nvPr/>
         </p:nvSpPr>
         <p:spPr>
-          <a:xfrm rot="16200000">
-            <a:off x="530352" y="4279392"/>
-            <a:ext cx="402336" cy="1325880"/>
-          </a:xfrm>
-          <a:prstGeom prst="rect">
-            <a:avLst/>
-          </a:prstGeom>
-          <a:noFill/>
-        </p:spPr>
-        <p:txBody>
-          <a:bodyPr wrap="square" lIns="0" rIns="0" tIns="0" bIns="0" anchor="ctr">
-            <a:spAutoFit/>
-          </a:bodyPr>
-          <a:lstStyle/>
-          <a:p>
-            <a:pPr algn="ctr">
+          <a:xfrm>
+            <a:off x="1463040" y="4137660"/>
+            <a:ext cx="1234440" cy="164592"/>
+          </a:xfrm>
+          <a:prstGeom prst="rect">
+            <a:avLst/>
+          </a:prstGeom>
+          <a:noFill/>
+        </p:spPr>
+        <p:txBody>
+          <a:bodyPr wrap="square" lIns="0" rIns="0" tIns="0" bIns="0" anchor="t">
+            <a:spAutoFit/>
+          </a:bodyPr>
+          <a:lstStyle/>
+          <a:p>
+            <a:pPr algn="l">
               <a:lnSpc>
                 <a:spcPct val="100000"/>
               </a:lnSpc>
@@ -13000,7 +13000,7 @@
               </a:spcAft>
             </a:pPr>
             <a:r>
-              <a:rPr sz="700" b="1" i="0">
+              <a:rPr sz="660" b="1" i="0">
                 <a:solidFill>
                   <a:srgbClr val="5E7082"/>
                 </a:solidFill>
@@ -21830,7 +21830,7 @@
         <p:spPr>
           <a:xfrm>
             <a:off x="786384" y="3611880"/>
-            <a:ext cx="987552" cy="283464"/>
+            <a:ext cx="1993392" cy="274320"/>
           </a:xfrm>
           <a:prstGeom prst="rect">
             <a:avLst/>
@@ -21855,7 +21855,7 @@
               </a:spcAft>
             </a:pPr>
             <a:r>
-              <a:rPr sz="1300" b="1" i="0">
+              <a:rPr sz="1250" b="1" i="0">
                 <a:solidFill>
                   <a:srgbClr val="00A58E"/>
                 </a:solidFill>
@@ -21874,8 +21874,8 @@
         </p:nvSpPr>
         <p:spPr>
           <a:xfrm>
-            <a:off x="1572768" y="3602736"/>
-            <a:ext cx="1490472" cy="448056"/>
+            <a:off x="786384" y="3931920"/>
+            <a:ext cx="1993392" cy="310896"/>
           </a:xfrm>
           <a:prstGeom prst="rect">
             <a:avLst/>
@@ -21900,7 +21900,7 @@
               </a:spcAft>
             </a:pPr>
             <a:r>
-              <a:rPr sz="800" b="0" i="0">
+              <a:rPr sz="760" b="0" i="0">
                 <a:solidFill>
                   <a:srgbClr val="C7D2DB"/>
                 </a:solidFill>
@@ -21920,7 +21920,7 @@
         <p:spPr>
           <a:xfrm>
             <a:off x="786384" y="4416552"/>
-            <a:ext cx="987552" cy="283464"/>
+            <a:ext cx="1993392" cy="274320"/>
           </a:xfrm>
           <a:prstGeom prst="rect">
             <a:avLst/>
@@ -21945,7 +21945,7 @@
               </a:spcAft>
             </a:pPr>
             <a:r>
-              <a:rPr sz="1300" b="1" i="0">
+              <a:rPr sz="1250" b="1" i="0">
                 <a:solidFill>
                   <a:srgbClr val="00A58E"/>
                 </a:solidFill>
@@ -21964,8 +21964,8 @@
         </p:nvSpPr>
         <p:spPr>
           <a:xfrm>
-            <a:off x="1572768" y="4407408"/>
-            <a:ext cx="1490472" cy="448056"/>
+            <a:off x="786384" y="4736592"/>
+            <a:ext cx="1993392" cy="310896"/>
           </a:xfrm>
           <a:prstGeom prst="rect">
             <a:avLst/>
@@ -21990,7 +21990,7 @@
               </a:spcAft>
             </a:pPr>
             <a:r>
-              <a:rPr sz="800" b="0" i="0">
+              <a:rPr sz="760" b="0" i="0">
                 <a:solidFill>
                   <a:srgbClr val="C7D2DB"/>
                 </a:solidFill>
@@ -22010,7 +22010,7 @@
         <p:spPr>
           <a:xfrm>
             <a:off x="786384" y="5221224"/>
-            <a:ext cx="987552" cy="283464"/>
+            <a:ext cx="1993392" cy="274320"/>
           </a:xfrm>
           <a:prstGeom prst="rect">
             <a:avLst/>
@@ -22035,7 +22035,7 @@
               </a:spcAft>
             </a:pPr>
             <a:r>
-              <a:rPr sz="1300" b="1" i="0">
+              <a:rPr sz="1250" b="1" i="0">
                 <a:solidFill>
                   <a:srgbClr val="00A58E"/>
                 </a:solidFill>
@@ -22054,8 +22054,8 @@
         </p:nvSpPr>
         <p:spPr>
           <a:xfrm>
-            <a:off x="1572768" y="5212080"/>
-            <a:ext cx="1490472" cy="448056"/>
+            <a:off x="786384" y="5541264"/>
+            <a:ext cx="1993392" cy="310896"/>
           </a:xfrm>
           <a:prstGeom prst="rect">
             <a:avLst/>
@@ -22080,7 +22080,7 @@
               </a:spcAft>
             </a:pPr>
             <a:r>
-              <a:rPr sz="800" b="0" i="0">
+              <a:rPr sz="760" b="0" i="0">
                 <a:solidFill>
                   <a:srgbClr val="C7D2DB"/>
                 </a:solidFill>
@@ -42486,7 +42486,7 @@
                 </a:solidFill>
                 <a:latin typeface="Lato"/>
               </a:rPr>
-              <a:t>The iPSC method converts adult cells into pluripotent stem cells.</a:t>
+              <a:t>The Nobel-winning iPSC method converts adult cells into pluripotent stem cells.</a:t>
             </a:r>
           </a:p>
         </p:txBody>
@@ -46632,8 +46632,8 @@
         </p:nvSpPr>
         <p:spPr>
           <a:xfrm>
-            <a:off x="530352" y="2587752"/>
-            <a:ext cx="1042415" cy="283464"/>
+            <a:off x="512063" y="2578608"/>
+            <a:ext cx="1078992" cy="283464"/>
           </a:xfrm>
           <a:prstGeom prst="rect">
             <a:avLst/>
@@ -46658,7 +46658,7 @@
               </a:spcAft>
             </a:pPr>
             <a:r>
-              <a:rPr sz="830" b="1" i="0">
+              <a:rPr sz="819" b="1" i="0">
                 <a:solidFill>
                   <a:srgbClr val="10243D"/>
                 </a:solidFill>
@@ -46677,8 +46677,8 @@
         </p:nvSpPr>
         <p:spPr>
           <a:xfrm>
-            <a:off x="521207" y="2898648"/>
-            <a:ext cx="1060704" cy="347472"/>
+            <a:off x="484631" y="2898648"/>
+            <a:ext cx="1133856" cy="365760"/>
           </a:xfrm>
           <a:prstGeom prst="rect">
             <a:avLst/>
@@ -46703,13 +46703,13 @@
               </a:spcAft>
             </a:pPr>
             <a:r>
-              <a:rPr sz="650" b="0" i="0">
+              <a:rPr sz="700" b="0" i="0">
                 <a:solidFill>
                   <a:srgbClr val="5E7082"/>
                 </a:solidFill>
                 <a:latin typeface="Lato"/>
               </a:rPr>
-              <a:t>First magnetic 3D bioprinter on ISS; tissue constructs created 2018–2020.</a:t>
+              <a:t>First magnetic bioprinter reaches ISS; constructs prove the approach.</a:t>
             </a:r>
           </a:p>
         </p:txBody>
@@ -46937,8 +46937,8 @@
         </p:nvSpPr>
         <p:spPr>
           <a:xfrm>
-            <a:off x="2194560" y="4837176"/>
-            <a:ext cx="1042415" cy="283464"/>
+            <a:off x="2176272" y="4828032"/>
+            <a:ext cx="1078992" cy="283464"/>
           </a:xfrm>
           <a:prstGeom prst="rect">
             <a:avLst/>
@@ -46963,7 +46963,7 @@
               </a:spcAft>
             </a:pPr>
             <a:r>
-              <a:rPr sz="830" b="1" i="0">
+              <a:rPr sz="819" b="1" i="0">
                 <a:solidFill>
                   <a:srgbClr val="10243D"/>
                 </a:solidFill>
@@ -46982,8 +46982,8 @@
         </p:nvSpPr>
         <p:spPr>
           <a:xfrm>
-            <a:off x="2185415" y="5148072"/>
-            <a:ext cx="1060704" cy="347472"/>
+            <a:off x="2148839" y="5148072"/>
+            <a:ext cx="1133856" cy="365760"/>
           </a:xfrm>
           <a:prstGeom prst="rect">
             <a:avLst/>
@@ -47008,13 +47008,13 @@
               </a:spcAft>
             </a:pPr>
             <a:r>
-              <a:rPr sz="650" b="0" i="0">
+              <a:rPr sz="700" b="0" i="0">
                 <a:solidFill>
                   <a:srgbClr val="5E7082"/>
                 </a:solidFill>
                 <a:latin typeface="Lato"/>
               </a:rPr>
-              <a:t>BioFabrication Facility reaches ISS; later named a Popular Science 2023 innovation.</a:t>
+              <a:t>BioFabrication Facility reaches ISS; later recognised by Popular Science.</a:t>
             </a:r>
           </a:p>
         </p:txBody>
@@ -47242,8 +47242,8 @@
         </p:nvSpPr>
         <p:spPr>
           <a:xfrm>
-            <a:off x="3858768" y="2587752"/>
-            <a:ext cx="1042415" cy="283464"/>
+            <a:off x="3840480" y="2578608"/>
+            <a:ext cx="1078992" cy="283464"/>
           </a:xfrm>
           <a:prstGeom prst="rect">
             <a:avLst/>
@@ -47268,7 +47268,7 @@
               </a:spcAft>
             </a:pPr>
             <a:r>
-              <a:rPr sz="830" b="1" i="0">
+              <a:rPr sz="819" b="1" i="0">
                 <a:solidFill>
                   <a:srgbClr val="10243D"/>
                 </a:solidFill>
@@ -47287,8 +47287,8 @@
         </p:nvSpPr>
         <p:spPr>
           <a:xfrm>
-            <a:off x="3849624" y="2898648"/>
-            <a:ext cx="1060704" cy="347472"/>
+            <a:off x="3813048" y="2898648"/>
+            <a:ext cx="1133856" cy="365760"/>
           </a:xfrm>
           <a:prstGeom prst="rect">
             <a:avLst/>
@@ -47313,13 +47313,13 @@
               </a:spcAft>
             </a:pPr>
             <a:r>
-              <a:rPr sz="650" b="0" i="0">
+              <a:rPr sz="700" b="0" i="0">
                 <a:solidFill>
                   <a:srgbClr val="5E7082"/>
                 </a:solidFill>
                 <a:latin typeface="Lato"/>
               </a:rPr>
-              <a:t>Handheld bioprinter demonstrated aboard the Cosmic Kiss mission.</a:t>
+              <a:t>Handheld skin-patch bioprinter demonstrated on Cosmic Kiss.</a:t>
             </a:r>
           </a:p>
         </p:txBody>
@@ -47547,8 +47547,8 @@
         </p:nvSpPr>
         <p:spPr>
           <a:xfrm>
-            <a:off x="5522975" y="4837176"/>
-            <a:ext cx="1042415" cy="283464"/>
+            <a:off x="5504688" y="4828032"/>
+            <a:ext cx="1078992" cy="283464"/>
           </a:xfrm>
           <a:prstGeom prst="rect">
             <a:avLst/>
@@ -47573,7 +47573,7 @@
               </a:spcAft>
             </a:pPr>
             <a:r>
-              <a:rPr sz="830" b="1" i="0">
+              <a:rPr sz="819" b="1" i="0">
                 <a:solidFill>
                   <a:srgbClr val="10243D"/>
                 </a:solidFill>
@@ -47592,8 +47592,8 @@
         </p:nvSpPr>
         <p:spPr>
           <a:xfrm>
-            <a:off x="5513831" y="5148072"/>
-            <a:ext cx="1060704" cy="347472"/>
+            <a:off x="5477255" y="5148072"/>
+            <a:ext cx="1133856" cy="365760"/>
           </a:xfrm>
           <a:prstGeom prst="rect">
             <a:avLst/>
@@ -47618,13 +47618,13 @@
               </a:spcAft>
             </a:pPr>
             <a:r>
-              <a:rPr sz="650" b="0" i="0">
+              <a:rPr sz="700" b="0" i="0">
                 <a:solidFill>
                   <a:srgbClr val="5E7082"/>
                 </a:solidFill>
                 <a:latin typeface="Lato"/>
               </a:rPr>
-              <a:t>Redwire prints the first human knee meniscus in orbit.</a:t>
+              <a:t>First human knee meniscus is printed in orbit.</a:t>
             </a:r>
           </a:p>
         </p:txBody>
@@ -47852,8 +47852,8 @@
         </p:nvSpPr>
         <p:spPr>
           <a:xfrm>
-            <a:off x="7187183" y="2587752"/>
-            <a:ext cx="1042415" cy="283464"/>
+            <a:off x="7168896" y="2578608"/>
+            <a:ext cx="1078992" cy="283464"/>
           </a:xfrm>
           <a:prstGeom prst="rect">
             <a:avLst/>
@@ -47878,7 +47878,7 @@
               </a:spcAft>
             </a:pPr>
             <a:r>
-              <a:rPr sz="830" b="1" i="0">
+              <a:rPr sz="819" b="1" i="0">
                 <a:solidFill>
                   <a:srgbClr val="10243D"/>
                 </a:solidFill>
@@ -47897,8 +47897,8 @@
         </p:nvSpPr>
         <p:spPr>
           <a:xfrm>
-            <a:off x="7178040" y="2898648"/>
-            <a:ext cx="1060704" cy="347472"/>
+            <a:off x="7141464" y="2898648"/>
+            <a:ext cx="1133856" cy="365760"/>
           </a:xfrm>
           <a:prstGeom prst="rect">
             <a:avLst/>
@@ -47923,13 +47923,13 @@
               </a:spcAft>
             </a:pPr>
             <a:r>
-              <a:rPr sz="650" b="0" i="0">
+              <a:rPr sz="700" b="0" i="0">
                 <a:solidFill>
                   <a:srgbClr val="5E7082"/>
                 </a:solidFill>
                 <a:latin typeface="Lato"/>
               </a:rPr>
-              <a:t>Redwire returns live 3D-bioprinted human cardiac tissue from ISS.</a:t>
+              <a:t>First live 3D-bioprinted human cardiac tissue returns.</a:t>
             </a:r>
           </a:p>
         </p:txBody>
@@ -48157,8 +48157,8 @@
         </p:nvSpPr>
         <p:spPr>
           <a:xfrm>
-            <a:off x="8851392" y="4837176"/>
-            <a:ext cx="1042415" cy="283464"/>
+            <a:off x="8833104" y="4828032"/>
+            <a:ext cx="1078992" cy="283464"/>
           </a:xfrm>
           <a:prstGeom prst="rect">
             <a:avLst/>
@@ -48183,7 +48183,7 @@
               </a:spcAft>
             </a:pPr>
             <a:r>
-              <a:rPr sz="830" b="1" i="0">
+              <a:rPr sz="819" b="1" i="0">
                 <a:solidFill>
                   <a:srgbClr val="10243D"/>
                 </a:solidFill>
@@ -48202,8 +48202,8 @@
         </p:nvSpPr>
         <p:spPr>
           <a:xfrm>
-            <a:off x="8842248" y="5148072"/>
-            <a:ext cx="1060704" cy="347472"/>
+            <a:off x="8805672" y="5148072"/>
+            <a:ext cx="1133856" cy="365760"/>
           </a:xfrm>
           <a:prstGeom prst="rect">
             <a:avLst/>
@@ -48228,13 +48228,13 @@
               </a:spcAft>
             </a:pPr>
             <a:r>
-              <a:rPr sz="650" b="0" i="0">
+              <a:rPr sz="700" b="0" i="0">
                 <a:solidFill>
                   <a:srgbClr val="5E7082"/>
                 </a:solidFill>
                 <a:latin typeface="Lato"/>
               </a:rPr>
-              <a:t>LambdaVision wins NASA InSPA Phase 2; Redwire receives $25M NASA IDIQ.</a:t>
+              <a:t>InSPA Phase 2 and a $25M NASA IDIQ expand the field.</a:t>
             </a:r>
           </a:p>
         </p:txBody>
@@ -48462,8 +48462,8 @@
         </p:nvSpPr>
         <p:spPr>
           <a:xfrm>
-            <a:off x="10515600" y="2587752"/>
-            <a:ext cx="1042415" cy="283464"/>
+            <a:off x="10497312" y="2578608"/>
+            <a:ext cx="1078992" cy="283464"/>
           </a:xfrm>
           <a:prstGeom prst="rect">
             <a:avLst/>
@@ -48488,7 +48488,7 @@
               </a:spcAft>
             </a:pPr>
             <a:r>
-              <a:rPr sz="830" b="1" i="0">
+              <a:rPr sz="819" b="1" i="0">
                 <a:solidFill>
                   <a:srgbClr val="10243D"/>
                 </a:solidFill>
@@ -48507,8 +48507,8 @@
         </p:nvSpPr>
         <p:spPr>
           <a:xfrm>
-            <a:off x="10506456" y="2898648"/>
-            <a:ext cx="1060704" cy="347472"/>
+            <a:off x="10469880" y="2898648"/>
+            <a:ext cx="1133856" cy="365760"/>
           </a:xfrm>
           <a:prstGeom prst="rect">
             <a:avLst/>
@@ -48533,13 +48533,13 @@
               </a:spcAft>
             </a:pPr>
             <a:r>
-              <a:rPr sz="650" b="0" i="0">
+              <a:rPr sz="700" b="0" i="0">
                 <a:solidFill>
                   <a:srgbClr val="5E7082"/>
                 </a:solidFill>
                 <a:latin typeface="Lato"/>
               </a:rPr>
-              <a:t>LambdaVision closes $7M seed as commercial-station payload slots open.</a:t>
+              <a:t>$7M seed and payload reservations signal commercial transition.</a:t>
             </a:r>
           </a:p>
         </p:txBody>

</xml_diff>